<commit_message>
Präsentation: Meta-Analyse als Beleg auf der Reflexions-Folie
Folie 2 nennt jetzt den Effekt strukturierter Rückblicke (rund 25 %) mit
Quelle Tannenbaum & Cerasoli (2013), Human Factors; Details und Einordnung
stehen in den Sprechernotizen.

Co-Authored-By: Claude Opus 5.5 <noreply@anthropic.com>
</commit_message>
<xml_diff>
--- a/praesentation/LimeJournal-Studie.pptx
+++ b/praesentation/LimeJournal-Studie.pptx
@@ -112,24 +112,24 @@
   <p:extLst>
     <p:ext uri="{521415D9-36F7-43E2-AB2F-B90AF26B5E84}">
       <p14:sectionLst xmlns:p14="http://schemas.microsoft.com/office/powerpoint/2010/main">
-        <p14:section name="Einstieg" id="{c2993613-3510-7817-1792-f3be068490ba}">
+        <p14:section name="Einstieg" id="{fe0f48d2-be85-f497-0918-2e8208f9a2ee}">
           <p14:sldIdLst>
             <p14:sldId id="256"/>
           </p14:sldIdLst>
         </p14:section>
-        <p14:section name="Warum Reflexion" id="{438c0138-42ec-3ac5-fc79-67fd064cf919}">
+        <p14:section name="Warum Reflexion" id="{9a1c088c-fa31-1682-41c9-55e2abf4ed9c}">
           <p14:sldIdLst>
             <p14:sldId id="257"/>
             <p14:sldId id="258"/>
           </p14:sldIdLst>
         </p14:section>
-        <p14:section name="LimeJournal" id="{b80e4c73-92b1-6ee2-8690-8712250f9432}">
+        <p14:section name="LimeJournal" id="{a5f1e0b0-7cba-b351-452e-1ffe9120bc75}">
           <p14:sldIdLst>
             <p14:sldId id="259"/>
             <p14:sldId id="260"/>
           </p14:sldIdLst>
         </p14:section>
-        <p14:section name="Mitmachen" id="{9099790d-a0ed-ea87-c9ab-7c7173f4f193}">
+        <p14:section name="Mitmachen" id="{e6cb6f9f-b092-9734-ad09-477d17e4cde7}">
           <p14:sldIdLst>
             <p14:sldId id="261"/>
           </p14:sldIdLst>
@@ -628,9 +628,12 @@
           <a:p>
             <a:r>
               <a:rPr lang="en-US" dirty="0"/>
-              <a:t>Ca. 45 Sekunden.
+              <a:t>Ca. 50 Sekunden.
 Wir erleben in einem Projekt jede Woche viel: Entscheidungen, Konflikte im Team, kleine Erfolge, Rückschläge. Gelernt wird daraus aber vor allem dann, wenn wir es nachträglich einordnen – was lief gut, was nicht, was mache ich nächstes Mal anders.
-Im Sport ist das selbstverständlich: Spielanalyse nach jedem Spiel, auch nach den verlorenen. In Projekten und im Studium machen wir das selten – weil es keinen festen Moment dafür gibt. Genau den schafft LimeJournal.</a:t>
+Im Sport ist das selbstverständlich: Spielanalyse nach jedem Spiel, auch nach den verlorenen. In Projekten und im Studium machen wir das selten – weil es keinen festen Moment dafür gibt. Genau den schafft LimeJournal.
+Dass sich das lohnt, ist gut belegt: Eine Meta-Analyse in Human Factors hat 46 Stichproben mit insgesamt 2.136 Personen ausgewertet. Strukturierte Rückblicke – sogenannte Debriefs – verbesserten die Leistung gegenüber Kontrollgruppen im Schnitt um rund 25 % (d = 0,67). Der Effekt war für Einzelpersonen ähnlich groß wie für Teams, im echten Einsatz wie in Simulationen und in medizinischen wie nicht-medizinischen Bereichen.
+Falls jemand nachfragt: Die Studien untersuchen meist strukturierte, oft moderierte Rückblicke nach einer Aufgabe – LimeJournal ist eine verwandte, aber eigene Form. Die 25 % sind also ein Hinweis, wie viel Rückblick bringen kann, kein Versprechen für die App.
+Quelle: Tannenbaum, S. I. &amp; Cerasoli, C. P. (2013). Do team and individual debriefs enhance performance? A meta-analysis. Human Factors, 55(1), 231–245. https://doi.org/10.1177/0018720812448394</a:t>
             </a:r>
             <a:endParaRPr lang="en-US" dirty="0"/>
           </a:p>
@@ -4173,9 +4176,76 @@
                   <a:schemeClr val="tx2"/>
                 </a:solidFill>
               </a:rPr>
-              <a:t>Profis im Sport schauen sich jedes Spiel noch einmal an. Das geht auch mit deiner Projektwoche.</a:t>
+              <a:t>Wer gezielt zurückblickt, schneidet im Schnitt </a:t>
+            </a:r>
+            <a:pPr algn="l" indent="0" marL="0">
+              <a:buNone/>
+            </a:pPr>
+            <a:r>
+              <a:rPr lang="en-US" sz="1800" b="1" dirty="0">
+                <a:solidFill>
+                  <a:schemeClr val="accent2"/>
+                </a:solidFill>
+              </a:rPr>
+              <a:t>rund 25 % besser</a:t>
+            </a:r>
+            <a:pPr algn="l" indent="0" marL="0">
+              <a:buNone/>
+            </a:pPr>
+            <a:r>
+              <a:rPr lang="en-US" sz="1800" dirty="0">
+                <a:solidFill>
+                  <a:schemeClr val="tx2"/>
+                </a:solidFill>
+              </a:rPr>
+              <a:t> ab.</a:t>
             </a:r>
             <a:endParaRPr lang="en-US" sz="1800" dirty="0"/>
+          </a:p>
+        </p:txBody>
+      </p:sp>
+      <p:sp>
+        <p:nvSpPr>
+          <p:cNvPr id="5" name="Quelle">
+            <a:hlinkClick r:id="rId1" tooltip=""/>
+          </p:cNvPr>
+          <p:cNvSpPr txBox="1"/>
+          <p:nvPr/>
+        </p:nvSpPr>
+        <p:spPr>
+          <a:xfrm>
+            <a:off x="548640" y="5394960"/>
+            <a:ext cx="9144000" cy="320040"/>
+          </a:xfrm>
+          <a:prstGeom prst="rect">
+            <a:avLst/>
+          </a:prstGeom>
+          <a:noFill/>
+          <a:ln/>
+        </p:spPr>
+        <p:txBody>
+          <a:bodyPr wrap="square" lIns="0" tIns="0" rIns="0" bIns="0" rtlCol="0" anchor="t"/>
+          <a:lstStyle/>
+          <a:p>
+            <a:pPr algn="l" indent="0" marL="0">
+              <a:buNone/>
+            </a:pPr>
+            <a:r>
+              <a:rPr lang="en-US" sz="1300" u="sng" dirty="0">
+                <a:solidFill>
+                  <a:schemeClr val="tx2"/>
+                </a:solidFill>
+                <a:hlinkClick r:id="rId1" invalidUrl="" action="" tgtFrame="" tooltip="" history="1" highlightClick="0" endSnd="0">
+                  <a:extLst>
+                    <a:ext uri="{A12FA001-AC4F-418D-AE19-62706E023703}">
+                      <ahyp:hlinkClr xmlns:ahyp="http://schemas.microsoft.com/office/drawing/2018/hyperlinkcolor" val="tx"/>
+                    </a:ext>
+                  </a:extLst>
+                </a:hlinkClick>
+              </a:rPr>
+              <a:t>Meta-Analyse aus 46 Stichproben mit 2.136 Personen · Tannenbaum &amp; Cerasoli (2013), Human Factors 55(1)</a:t>
+            </a:r>
+            <a:endParaRPr lang="en-US" sz="1300" dirty="0"/>
           </a:p>
         </p:txBody>
       </p:sp>

</xml_diff>

<commit_message>
Präsentation: „Teilnahme beenden“ nicht mehr als Menüpunkt nennen
Folie 5 sagt nur noch, dass man jederzeit aufhören kann; die Notizen verweisen
für den Weg dorthin auf die Datenschutzinformation.

Co-Authored-By: Claude Opus 5.5 <noreply@anthropic.com>
</commit_message>
<xml_diff>
--- a/praesentation/LimeJournal-Studie.pptx
+++ b/praesentation/LimeJournal-Studie.pptx
@@ -112,24 +112,24 @@
   <p:extLst>
     <p:ext uri="{521415D9-36F7-43E2-AB2F-B90AF26B5E84}">
       <p14:sectionLst xmlns:p14="http://schemas.microsoft.com/office/powerpoint/2010/main">
-        <p14:section name="Einstieg" id="{fe0f48d2-be85-f497-0918-2e8208f9a2ee}">
+        <p14:section name="Einstieg" id="{68a98633-7016-caf0-44d3-57f4749d1bcd}">
           <p14:sldIdLst>
             <p14:sldId id="256"/>
           </p14:sldIdLst>
         </p14:section>
-        <p14:section name="Warum Reflexion" id="{9a1c088c-fa31-1682-41c9-55e2abf4ed9c}">
+        <p14:section name="Warum Reflexion" id="{7bb2c12e-b68a-efcf-e610-b3143158ddc2}">
           <p14:sldIdLst>
             <p14:sldId id="257"/>
             <p14:sldId id="258"/>
           </p14:sldIdLst>
         </p14:section>
-        <p14:section name="LimeJournal" id="{a5f1e0b0-7cba-b351-452e-1ffe9120bc75}">
+        <p14:section name="LimeJournal" id="{5630c297-b041-5202-3149-15b71a04af24}">
           <p14:sldIdLst>
             <p14:sldId id="259"/>
             <p14:sldId id="260"/>
           </p14:sldIdLst>
         </p14:section>
-        <p14:section name="Mitmachen" id="{e6cb6f9f-b092-9734-ad09-477d17e4cde7}">
+        <p14:section name="Mitmachen" id="{e31a073a-752e-a486-fc1c-0158dc145f22}">
           <p14:sldIdLst>
             <p14:sldId id="261"/>
           </p14:sldIdLst>
@@ -907,7 +907,7 @@
               <a:t>Ca. 60 Sekunden – diese Folie ist wichtig, ruhig Zeit lassen.
 Freiwillig: Teilnahme, Antworten oder Aufhören haben keinen Einfluss auf Noten oder Studium. Ich beginne mit der Auswertung erst, wenn die Leistungen in der Lehrveranstaltung bewertet sind.
 Anonym: Gespeichert werden weder echter Name noch E-Mail noch Matrikelnummer. Weil ich die Aufnahmen anhöre, könnte ich Stimmen erkennen – ich nutze die Daten aber nie für Bewertungen. Bitte nennt in den Aufnahmen keine Namen anderer Personen. Server stehen in Deutschland; die Transkription läuft über einen Anbieter in der EU, die Aufnahmen werden dort nicht gespeichert und nicht zum KI-Training genutzt.
-Jederzeit raus: Im Menü „Teilnahme beenden“ – danach ist sofort alles gelöscht. Die vollständige Datenschutzinformation steht in der App und im Informationsschreiben.</a:t>
+Jederzeit raus: Ihr könnt jederzeit ohne Angabe von Gründen aufhören. Wie das geht, steht in der Datenschutzinformation – in der App und im Informationsschreiben. Danach sind Konto, Einträge und Aufnahmen sofort gelöscht.</a:t>
             </a:r>
             <a:endParaRPr lang="en-US" dirty="0"/>
           </a:p>
@@ -5868,7 +5868,7 @@
                   <a:schemeClr val="tx2"/>
                 </a:solidFill>
               </a:rPr>
-              <a:t>„Teilnahme beenden“ löscht Konto, Einträge und Aufnahmen sofort.</a:t>
+              <a:t>Du kannst jederzeit aufhören. Konto, Einträge und Aufnahmen sind dann sofort gelöscht.</a:t>
             </a:r>
             <a:endParaRPr lang="en-US" sz="1700" dirty="0"/>
           </a:p>

</xml_diff>